<commit_message>
feat: add new agents for coding, debugging, design, documentation sync, and exploration; update CLAUDE.md with tool priority and usage guidelines
</commit_message>
<xml_diff>
--- a/docs/2026-08-11-Tong-Quan-Du-An.pptx
+++ b/docs/2026-08-11-Tong-Quan-Du-An.pptx
@@ -5,7 +5,7 @@
     <p:sldMasterId id="2147483648" r:id="rId1"/>
   </p:sldMasterIdLst>
   <p:notesMasterIdLst>
-    <p:notesMasterId r:id="rId19"/>
+    <p:notesMasterId r:id="rId18"/>
   </p:notesMasterIdLst>
   <p:sldIdLst>
     <p:sldId id="256" r:id="rId2"/>
@@ -24,7 +24,6 @@
     <p:sldId id="269" r:id="rId15"/>
     <p:sldId id="270" r:id="rId16"/>
     <p:sldId id="271" r:id="rId17"/>
-    <p:sldId id="272" r:id="rId18"/>
   </p:sldIdLst>
   <p:sldSz cx="12192000" cy="6858000"/>
   <p:notesSz cx="6858000" cy="9144000"/>
@@ -971,72 +970,6 @@
 </p:notes>
 </file>
 
-<file path=ppt/notesSlides/notesSlide17.xml><?xml version="1.0" encoding="utf-8"?>
-<p:notes xmlns:a="http://schemas.openxmlformats.org/drawingml/2006/main" xmlns:r="http://schemas.openxmlformats.org/officeDocument/2006/relationships" xmlns:p="http://schemas.openxmlformats.org/presentationml/2006/main">
-  <p:cSld>
-    <p:spTree>
-      <p:nvGrpSpPr>
-        <p:cNvPr id="1" name=""/>
-        <p:cNvGrpSpPr/>
-        <p:nvPr/>
-      </p:nvGrpSpPr>
-      <p:grpSpPr>
-        <a:xfrm>
-          <a:off x="0" y="0"/>
-          <a:ext cx="0" cy="0"/>
-          <a:chOff x="0" y="0"/>
-          <a:chExt cx="0" cy="0"/>
-        </a:xfrm>
-      </p:grpSpPr>
-      <p:sp>
-        <p:nvSpPr>
-          <p:cNvPr id="2" name="Slide Image Placeholder 1"/>
-          <p:cNvSpPr>
-            <a:spLocks noGrp="1" noRot="1" noChangeAspect="1"/>
-          </p:cNvSpPr>
-          <p:nvPr>
-            <p:ph type="sldImg"/>
-          </p:nvPr>
-        </p:nvSpPr>
-        <p:spPr/>
-        <p:txBody>
-          <a:bodyPr/>
-          <a:lstStyle/>
-          <a:p>
-            <a:endParaRPr/>
-          </a:p>
-        </p:txBody>
-      </p:sp>
-      <p:sp>
-        <p:nvSpPr>
-          <p:cNvPr id="3" name="Notes Placeholder 2"/>
-          <p:cNvSpPr>
-            <a:spLocks noGrp="1"/>
-          </p:cNvSpPr>
-          <p:nvPr>
-            <p:ph type="body" idx="1"/>
-          </p:nvPr>
-        </p:nvSpPr>
-        <p:spPr/>
-        <p:txBody>
-          <a:bodyPr/>
-          <a:lstStyle/>
-          <a:p>
-            <a:r>
-              <a:rPr lang="en-US"/>
-              <a:t>Cảm ơn mọi người đã theo dõi. Rất mong nhận được góp ý để hoàn thiện hệ thống trước khi kết nối dữ liệu thật từ portal.</a:t>
-            </a:r>
-          </a:p>
-        </p:txBody>
-      </p:sp>
-    </p:spTree>
-  </p:cSld>
-  <p:clrMapOvr>
-    <a:masterClrMapping/>
-  </p:clrMapOvr>
-</p:notes>
-</file>
-
 <file path=ppt/notesSlides/notesSlide2.xml><?xml version="1.0" encoding="utf-8"?>
 <p:notes xmlns:a="http://schemas.openxmlformats.org/drawingml/2006/main" xmlns:r="http://schemas.openxmlformats.org/officeDocument/2006/relationships" xmlns:p="http://schemas.openxmlformats.org/presentationml/2006/main">
   <p:cSld>
@@ -1906,10 +1839,10 @@
       </p:grpSpPr>
       <p:sp>
         <p:nvSpPr>
-          <p:cNvPr id="4" name="9Slide.vn - 2019">
+          <p:cNvPr id="7" name="9Slide.vn - 2019">
             <a:extLst>
               <a:ext uri="{FF2B5EF4-FFF2-40B4-BE49-F238E27FC236}">
-                <a16:creationId xmlns:a16="http://schemas.microsoft.com/office/drawing/2014/main" id="{5E81E42F-F90E-F47D-72A7-9F86F815FCE0}"/>
+                <a16:creationId xmlns:a16="http://schemas.microsoft.com/office/drawing/2014/main" id="{949AAD48-5101-7579-EC6D-1DC44B6EE986}"/>
               </a:ext>
             </a:extLst>
           </p:cNvPr>
@@ -5352,170 +5285,6 @@
 </p:sld>
 </file>
 
-<file path=ppt/slides/slide17.xml><?xml version="1.0" encoding="utf-8"?>
-<p:sld xmlns:a="http://schemas.openxmlformats.org/drawingml/2006/main" xmlns:r="http://schemas.openxmlformats.org/officeDocument/2006/relationships" xmlns:p="http://schemas.openxmlformats.org/presentationml/2006/main">
-  <p:cSld>
-    <p:bg>
-      <p:bgPr>
-        <a:solidFill>
-          <a:srgbClr val="1B2430"/>
-        </a:solidFill>
-        <a:effectLst/>
-      </p:bgPr>
-    </p:bg>
-    <p:spTree>
-      <p:nvGrpSpPr>
-        <p:cNvPr id="1" name=""/>
-        <p:cNvGrpSpPr/>
-        <p:nvPr/>
-      </p:nvGrpSpPr>
-      <p:grpSpPr>
-        <a:xfrm>
-          <a:off x="0" y="0"/>
-          <a:ext cx="0" cy="0"/>
-          <a:chOff x="0" y="0"/>
-          <a:chExt cx="0" cy="0"/>
-        </a:xfrm>
-      </p:grpSpPr>
-      <p:sp>
-        <p:nvSpPr>
-          <p:cNvPr id="100168" name="TextBox 1"/>
-          <p:cNvSpPr txBox="1"/>
-          <p:nvPr/>
-        </p:nvSpPr>
-        <p:spPr>
-          <a:xfrm>
-            <a:off x="720000" y="2664000"/>
-            <a:ext cx="10753200" cy="864000"/>
-          </a:xfrm>
-          <a:prstGeom prst="rect">
-            <a:avLst/>
-          </a:prstGeom>
-        </p:spPr>
-        <p:txBody>
-          <a:bodyPr/>
-          <a:lstStyle/>
-          <a:p>
-            <a:pPr algn="ctr"/>
-            <a:r>
-              <a:rPr lang="en-US" sz="4000" b="1">
-                <a:solidFill>
-                  <a:srgbClr val="FFFFFF"/>
-                </a:solidFill>
-                <a:latin typeface="Trebuchet MS"/>
-                <a:ea typeface="Trebuchet MS"/>
-              </a:rPr>
-              <a:t>CẢM ƠN ĐÃ THEO DÕI</a:t>
-            </a:r>
-          </a:p>
-        </p:txBody>
-      </p:sp>
-      <p:sp>
-        <p:nvSpPr>
-          <p:cNvPr id="100169" name="TextBox 2"/>
-          <p:cNvSpPr txBox="1"/>
-          <p:nvPr/>
-        </p:nvSpPr>
-        <p:spPr>
-          <a:xfrm>
-            <a:off x="720000" y="3564000"/>
-            <a:ext cx="10753200" cy="432000"/>
-          </a:xfrm>
-          <a:prstGeom prst="rect">
-            <a:avLst/>
-          </a:prstGeom>
-        </p:spPr>
-        <p:txBody>
-          <a:bodyPr/>
-          <a:lstStyle/>
-          <a:p>
-            <a:pPr algn="ctr"/>
-            <a:r>
-              <a:rPr lang="en-US" sz="2000" b="1">
-                <a:solidFill>
-                  <a:srgbClr val="DB0829"/>
-                </a:solidFill>
-                <a:latin typeface="Trebuchet MS"/>
-                <a:ea typeface="Trebuchet MS"/>
-              </a:rPr>
-              <a:t>IZONE Label Dashboard — Hệ thống Dán nhãn &amp; Cảnh báo sớm Học viên</a:t>
-            </a:r>
-          </a:p>
-        </p:txBody>
-      </p:sp>
-      <p:sp>
-        <p:nvSpPr>
-          <p:cNvPr id="100170" name="TextBox 3"/>
-          <p:cNvSpPr txBox="1"/>
-          <p:nvPr/>
-        </p:nvSpPr>
-        <p:spPr>
-          <a:xfrm>
-            <a:off x="720000" y="4176000"/>
-            <a:ext cx="10753200" cy="360000"/>
-          </a:xfrm>
-          <a:prstGeom prst="rect">
-            <a:avLst/>
-          </a:prstGeom>
-        </p:spPr>
-        <p:txBody>
-          <a:bodyPr/>
-          <a:lstStyle/>
-          <a:p>
-            <a:pPr algn="ctr"/>
-            <a:r>
-              <a:rPr lang="en-US" sz="1600">
-                <a:solidFill>
-                  <a:srgbClr val="B7C0CC"/>
-                </a:solidFill>
-                <a:latin typeface="Calibri"/>
-                <a:ea typeface="Calibri"/>
-              </a:rPr>
-              <a:t>Liên hệ: Nguyễn Ngọc Bảo Hà — Trưởng Khối  ·  ha.nnb@izone.edu.vn</a:t>
-            </a:r>
-          </a:p>
-        </p:txBody>
-      </p:sp>
-      <p:sp>
-        <p:nvSpPr>
-          <p:cNvPr id="100171" name="TextBox 4"/>
-          <p:cNvSpPr/>
-          <p:nvPr/>
-        </p:nvSpPr>
-        <p:spPr>
-          <a:xfrm>
-            <a:off x="0" y="6732000"/>
-            <a:ext cx="12193200" cy="126000"/>
-          </a:xfrm>
-          <a:prstGeom prst="rect">
-            <a:avLst/>
-          </a:prstGeom>
-          <a:solidFill>
-            <a:srgbClr val="DB0829"/>
-          </a:solidFill>
-          <a:ln>
-            <a:noFill/>
-          </a:ln>
-        </p:spPr>
-        <p:txBody>
-          <a:bodyPr/>
-          <a:lstStyle/>
-          <a:p>
-            <a:endParaRPr/>
-          </a:p>
-        </p:txBody>
-      </p:sp>
-    </p:spTree>
-  </p:cSld>
-  <p:clrMapOvr>
-    <a:masterClrMapping/>
-  </p:clrMapOvr>
-  <p:transition>
-    <p:fade/>
-  </p:transition>
-</p:sld>
-</file>
-
 <file path=ppt/slides/slide2.xml><?xml version="1.0" encoding="utf-8"?>
 <p:sld xmlns:a="http://schemas.openxmlformats.org/drawingml/2006/main" xmlns:r="http://schemas.openxmlformats.org/officeDocument/2006/relationships" xmlns:p="http://schemas.openxmlformats.org/presentationml/2006/main">
   <p:cSld>
@@ -6911,418 +6680,512 @@
           </a:p>
         </p:txBody>
       </p:sp>
-      <p:sp>
-        <p:nvSpPr>
-          <p:cNvPr id="100042" name="TextBox 3"/>
-          <p:cNvSpPr/>
-          <p:nvPr/>
-        </p:nvSpPr>
-        <p:spPr>
+      <p:grpSp>
+        <p:nvGrpSpPr>
+          <p:cNvPr id="2" name="Group 1">
+            <a:extLst>
+              <a:ext uri="{FF2B5EF4-FFF2-40B4-BE49-F238E27FC236}">
+                <a16:creationId xmlns:a16="http://schemas.microsoft.com/office/drawing/2014/main" id="{02EE19AE-C7C9-A192-54D7-B23E638FD8F2}"/>
+              </a:ext>
+            </a:extLst>
+          </p:cNvPr>
+          <p:cNvGrpSpPr/>
+          <p:nvPr/>
+        </p:nvGrpSpPr>
+        <p:grpSpPr>
           <a:xfrm>
             <a:off x="612000" y="1368000"/>
-            <a:ext cx="612000" cy="612000"/>
-          </a:xfrm>
-          <a:prstGeom prst="ellipse">
-            <a:avLst/>
-          </a:prstGeom>
-          <a:solidFill>
-            <a:srgbClr val="DB0829"/>
-          </a:solidFill>
-          <a:ln>
-            <a:noFill/>
-          </a:ln>
-        </p:spPr>
-        <p:txBody>
-          <a:bodyPr anchor="ctr"/>
-          <a:lstStyle/>
-          <a:p>
-            <a:pPr algn="ctr"/>
-            <a:r>
-              <a:rPr lang="en-US" sz="2200" b="1">
-                <a:solidFill>
-                  <a:srgbClr val="FFFFFF"/>
-                </a:solidFill>
-                <a:latin typeface="Trebuchet MS"/>
-                <a:ea typeface="Trebuchet MS"/>
-              </a:rPr>
-              <a:t>1</a:t>
-            </a:r>
-          </a:p>
-        </p:txBody>
-      </p:sp>
-      <p:sp>
-        <p:nvSpPr>
-          <p:cNvPr id="100043" name="TextBox 4"/>
-          <p:cNvSpPr txBox="1"/>
-          <p:nvPr/>
-        </p:nvSpPr>
-        <p:spPr>
-          <a:xfrm>
-            <a:off x="1476000" y="1422000"/>
-            <a:ext cx="10044000" cy="414000"/>
-          </a:xfrm>
-          <a:prstGeom prst="rect">
-            <a:avLst/>
-          </a:prstGeom>
-        </p:spPr>
-        <p:txBody>
-          <a:bodyPr/>
-          <a:lstStyle/>
-          <a:p>
-            <a:r>
-              <a:rPr lang="en-US" sz="2000" b="1">
-                <a:solidFill>
-                  <a:srgbClr val="1B2430"/>
-                </a:solidFill>
-                <a:latin typeface="Trebuchet MS"/>
-                <a:ea typeface="Trebuchet MS"/>
-              </a:rPr>
-              <a:t>Chuẩn hoá một bộ quy tắc đánh giá duy nhất</a:t>
-            </a:r>
-          </a:p>
-        </p:txBody>
-      </p:sp>
-      <p:sp>
-        <p:nvSpPr>
-          <p:cNvPr id="100044" name="TextBox 5"/>
-          <p:cNvSpPr txBox="1"/>
-          <p:nvPr/>
-        </p:nvSpPr>
-        <p:spPr>
-          <a:xfrm>
-            <a:off x="1476000" y="1782000"/>
-            <a:ext cx="10044000" cy="648000"/>
-          </a:xfrm>
-          <a:prstGeom prst="rect">
-            <a:avLst/>
-          </a:prstGeom>
-        </p:spPr>
-        <p:txBody>
-          <a:bodyPr/>
-          <a:lstStyle/>
-          <a:p>
-            <a:r>
-              <a:rPr lang="en-US" sz="1800">
-                <a:solidFill>
-                  <a:srgbClr val="7A8794"/>
-                </a:solidFill>
-                <a:latin typeface="Calibri"/>
-                <a:ea typeface="Calibri"/>
-              </a:rPr>
-              <a:t>Ngưỡng gán nhãn, điều kiện pass chuẩn, pass mềm áp dụng thống nhất toàn khối — thay vì phụ thuộc đánh giá cảm tính của từng giáo viên.</a:t>
-            </a:r>
-          </a:p>
-        </p:txBody>
-      </p:sp>
-      <p:sp>
-        <p:nvSpPr>
-          <p:cNvPr id="100045" name="TextBox 6"/>
-          <p:cNvSpPr/>
-          <p:nvPr/>
-        </p:nvSpPr>
-        <p:spPr>
+            <a:ext cx="10908000" cy="1062000"/>
+            <a:chOff x="612000" y="1368000"/>
+            <a:chExt cx="10908000" cy="1062000"/>
+          </a:xfrm>
+        </p:grpSpPr>
+        <p:sp>
+          <p:nvSpPr>
+            <p:cNvPr id="100042" name="TextBox 3"/>
+            <p:cNvSpPr/>
+            <p:nvPr/>
+          </p:nvSpPr>
+          <p:spPr>
+            <a:xfrm>
+              <a:off x="612000" y="1368000"/>
+              <a:ext cx="612000" cy="612000"/>
+            </a:xfrm>
+            <a:prstGeom prst="ellipse">
+              <a:avLst/>
+            </a:prstGeom>
+            <a:solidFill>
+              <a:srgbClr val="DB0829"/>
+            </a:solidFill>
+            <a:ln>
+              <a:noFill/>
+            </a:ln>
+          </p:spPr>
+          <p:txBody>
+            <a:bodyPr anchor="ctr"/>
+            <a:lstStyle/>
+            <a:p>
+              <a:pPr algn="ctr"/>
+              <a:r>
+                <a:rPr lang="en-US" sz="2200" b="1">
+                  <a:solidFill>
+                    <a:srgbClr val="FFFFFF"/>
+                  </a:solidFill>
+                  <a:latin typeface="Trebuchet MS"/>
+                  <a:ea typeface="Trebuchet MS"/>
+                </a:rPr>
+                <a:t>1</a:t>
+              </a:r>
+            </a:p>
+          </p:txBody>
+        </p:sp>
+        <p:sp>
+          <p:nvSpPr>
+            <p:cNvPr id="100043" name="TextBox 4"/>
+            <p:cNvSpPr txBox="1"/>
+            <p:nvPr/>
+          </p:nvSpPr>
+          <p:spPr>
+            <a:xfrm>
+              <a:off x="1476000" y="1422000"/>
+              <a:ext cx="10044000" cy="414000"/>
+            </a:xfrm>
+            <a:prstGeom prst="rect">
+              <a:avLst/>
+            </a:prstGeom>
+          </p:spPr>
+          <p:txBody>
+            <a:bodyPr/>
+            <a:lstStyle/>
+            <a:p>
+              <a:r>
+                <a:rPr lang="en-US" sz="2000" b="1">
+                  <a:solidFill>
+                    <a:srgbClr val="1B2430"/>
+                  </a:solidFill>
+                  <a:latin typeface="Trebuchet MS"/>
+                  <a:ea typeface="Trebuchet MS"/>
+                </a:rPr>
+                <a:t>Chuẩn hoá một bộ quy tắc đánh giá duy nhất</a:t>
+              </a:r>
+            </a:p>
+          </p:txBody>
+        </p:sp>
+        <p:sp>
+          <p:nvSpPr>
+            <p:cNvPr id="100044" name="TextBox 5"/>
+            <p:cNvSpPr txBox="1"/>
+            <p:nvPr/>
+          </p:nvSpPr>
+          <p:spPr>
+            <a:xfrm>
+              <a:off x="1476000" y="1782000"/>
+              <a:ext cx="10044000" cy="648000"/>
+            </a:xfrm>
+            <a:prstGeom prst="rect">
+              <a:avLst/>
+            </a:prstGeom>
+          </p:spPr>
+          <p:txBody>
+            <a:bodyPr/>
+            <a:lstStyle/>
+            <a:p>
+              <a:r>
+                <a:rPr lang="en-US" sz="1800">
+                  <a:solidFill>
+                    <a:srgbClr val="7A8794"/>
+                  </a:solidFill>
+                  <a:latin typeface="Calibri"/>
+                  <a:ea typeface="Calibri"/>
+                </a:rPr>
+                <a:t>Ngưỡng gán nhãn, điều kiện pass chuẩn, pass mềm áp dụng thống nhất toàn khối</a:t>
+              </a:r>
+            </a:p>
+          </p:txBody>
+        </p:sp>
+      </p:grpSp>
+      <p:grpSp>
+        <p:nvGrpSpPr>
+          <p:cNvPr id="3" name="Group 2">
+            <a:extLst>
+              <a:ext uri="{FF2B5EF4-FFF2-40B4-BE49-F238E27FC236}">
+                <a16:creationId xmlns:a16="http://schemas.microsoft.com/office/drawing/2014/main" id="{870AF5A5-5742-8355-BBF0-07BA84093B83}"/>
+              </a:ext>
+            </a:extLst>
+          </p:cNvPr>
+          <p:cNvGrpSpPr/>
+          <p:nvPr/>
+        </p:nvGrpSpPr>
+        <p:grpSpPr>
           <a:xfrm>
             <a:off x="612000" y="2628000"/>
-            <a:ext cx="612000" cy="612000"/>
-          </a:xfrm>
-          <a:prstGeom prst="ellipse">
-            <a:avLst/>
-          </a:prstGeom>
-          <a:solidFill>
-            <a:srgbClr val="DB0829"/>
-          </a:solidFill>
-          <a:ln>
-            <a:noFill/>
-          </a:ln>
-        </p:spPr>
-        <p:txBody>
-          <a:bodyPr anchor="ctr"/>
-          <a:lstStyle/>
-          <a:p>
-            <a:pPr algn="ctr"/>
-            <a:r>
-              <a:rPr lang="en-US" sz="2200" b="1">
-                <a:solidFill>
-                  <a:srgbClr val="FFFFFF"/>
-                </a:solidFill>
-                <a:latin typeface="Trebuchet MS"/>
-                <a:ea typeface="Trebuchet MS"/>
-              </a:rPr>
-              <a:t>2</a:t>
-            </a:r>
-          </a:p>
-        </p:txBody>
-      </p:sp>
-      <p:sp>
-        <p:nvSpPr>
-          <p:cNvPr id="100046" name="TextBox 7"/>
-          <p:cNvSpPr txBox="1"/>
-          <p:nvPr/>
-        </p:nvSpPr>
-        <p:spPr>
-          <a:xfrm>
-            <a:off x="1476000" y="2682000"/>
-            <a:ext cx="10044000" cy="414000"/>
-          </a:xfrm>
-          <a:prstGeom prst="rect">
-            <a:avLst/>
-          </a:prstGeom>
-        </p:spPr>
-        <p:txBody>
-          <a:bodyPr/>
-          <a:lstStyle/>
-          <a:p>
-            <a:r>
-              <a:rPr lang="en-US" sz="2000" b="1">
-                <a:solidFill>
-                  <a:srgbClr val="1B2430"/>
-                </a:solidFill>
-                <a:latin typeface="Trebuchet MS"/>
-                <a:ea typeface="Trebuchet MS"/>
-              </a:rPr>
-              <a:t>Rút ngắn thời gian phát hiện học viên rủi ro</a:t>
-            </a:r>
-          </a:p>
-        </p:txBody>
-      </p:sp>
-      <p:sp>
-        <p:nvSpPr>
-          <p:cNvPr id="100047" name="TextBox 8"/>
-          <p:cNvSpPr txBox="1"/>
-          <p:nvPr/>
-        </p:nvSpPr>
-        <p:spPr>
-          <a:xfrm>
-            <a:off x="1476000" y="3042000"/>
-            <a:ext cx="10044000" cy="648000"/>
-          </a:xfrm>
-          <a:prstGeom prst="rect">
-            <a:avLst/>
-          </a:prstGeom>
-        </p:spPr>
-        <p:txBody>
-          <a:bodyPr/>
-          <a:lstStyle/>
-          <a:p>
-            <a:r>
-              <a:rPr lang="en-US" sz="1800">
-                <a:solidFill>
-                  <a:srgbClr val="7A8794"/>
-                </a:solidFill>
-                <a:latin typeface="Calibri"/>
-                <a:ea typeface="Calibri"/>
-              </a:rPr>
-              <a:t>Từ chu kỳ rà soát hàng tuần trên Sheets, xuống gần như tức thời ngay khi có dữ liệu điểm danh, BTVN hoặc test mới.</a:t>
-            </a:r>
-          </a:p>
-        </p:txBody>
-      </p:sp>
-      <p:sp>
-        <p:nvSpPr>
-          <p:cNvPr id="100048" name="TextBox 9"/>
-          <p:cNvSpPr/>
-          <p:nvPr/>
-        </p:nvSpPr>
-        <p:spPr>
+            <a:ext cx="10908000" cy="1062000"/>
+            <a:chOff x="612000" y="2628000"/>
+            <a:chExt cx="10908000" cy="1062000"/>
+          </a:xfrm>
+        </p:grpSpPr>
+        <p:sp>
+          <p:nvSpPr>
+            <p:cNvPr id="100045" name="TextBox 6"/>
+            <p:cNvSpPr/>
+            <p:nvPr/>
+          </p:nvSpPr>
+          <p:spPr>
+            <a:xfrm>
+              <a:off x="612000" y="2628000"/>
+              <a:ext cx="612000" cy="612000"/>
+            </a:xfrm>
+            <a:prstGeom prst="ellipse">
+              <a:avLst/>
+            </a:prstGeom>
+            <a:solidFill>
+              <a:srgbClr val="DB0829"/>
+            </a:solidFill>
+            <a:ln>
+              <a:noFill/>
+            </a:ln>
+          </p:spPr>
+          <p:txBody>
+            <a:bodyPr anchor="ctr"/>
+            <a:lstStyle/>
+            <a:p>
+              <a:pPr algn="ctr"/>
+              <a:r>
+                <a:rPr lang="en-US" sz="2200" b="1">
+                  <a:solidFill>
+                    <a:srgbClr val="FFFFFF"/>
+                  </a:solidFill>
+                  <a:latin typeface="Trebuchet MS"/>
+                  <a:ea typeface="Trebuchet MS"/>
+                </a:rPr>
+                <a:t>2</a:t>
+              </a:r>
+            </a:p>
+          </p:txBody>
+        </p:sp>
+        <p:sp>
+          <p:nvSpPr>
+            <p:cNvPr id="100046" name="TextBox 7"/>
+            <p:cNvSpPr txBox="1"/>
+            <p:nvPr/>
+          </p:nvSpPr>
+          <p:spPr>
+            <a:xfrm>
+              <a:off x="1476000" y="2682000"/>
+              <a:ext cx="10044000" cy="414000"/>
+            </a:xfrm>
+            <a:prstGeom prst="rect">
+              <a:avLst/>
+            </a:prstGeom>
+          </p:spPr>
+          <p:txBody>
+            <a:bodyPr/>
+            <a:lstStyle/>
+            <a:p>
+              <a:r>
+                <a:rPr lang="en-US" sz="2000" b="1">
+                  <a:solidFill>
+                    <a:srgbClr val="1B2430"/>
+                  </a:solidFill>
+                  <a:latin typeface="Trebuchet MS"/>
+                  <a:ea typeface="Trebuchet MS"/>
+                </a:rPr>
+                <a:t>Rút ngắn thời gian phát hiện học viên rủi ro</a:t>
+              </a:r>
+            </a:p>
+          </p:txBody>
+        </p:sp>
+        <p:sp>
+          <p:nvSpPr>
+            <p:cNvPr id="100047" name="TextBox 8"/>
+            <p:cNvSpPr txBox="1"/>
+            <p:nvPr/>
+          </p:nvSpPr>
+          <p:spPr>
+            <a:xfrm>
+              <a:off x="1476000" y="3042000"/>
+              <a:ext cx="10044000" cy="648000"/>
+            </a:xfrm>
+            <a:prstGeom prst="rect">
+              <a:avLst/>
+            </a:prstGeom>
+          </p:spPr>
+          <p:txBody>
+            <a:bodyPr/>
+            <a:lstStyle/>
+            <a:p>
+              <a:r>
+                <a:rPr lang="en-US">
+                  <a:solidFill>
+                    <a:srgbClr val="7A8794"/>
+                  </a:solidFill>
+                  <a:latin typeface="Calibri"/>
+                  <a:ea typeface="Calibri"/>
+                </a:rPr>
+                <a:t>Cập nhật hàng ngày, vào 1 khung giờ nhất định, </a:t>
+              </a:r>
+              <a:r>
+                <a:rPr lang="en-US" sz="1800">
+                  <a:solidFill>
+                    <a:srgbClr val="7A8794"/>
+                  </a:solidFill>
+                  <a:latin typeface="Calibri"/>
+                  <a:ea typeface="Calibri"/>
+                </a:rPr>
+                <a:t>khi có dữ liệu điểm danh, BTVN hoặc test mới.</a:t>
+              </a:r>
+            </a:p>
+          </p:txBody>
+        </p:sp>
+      </p:grpSp>
+      <p:grpSp>
+        <p:nvGrpSpPr>
+          <p:cNvPr id="4" name="Group 3">
+            <a:extLst>
+              <a:ext uri="{FF2B5EF4-FFF2-40B4-BE49-F238E27FC236}">
+                <a16:creationId xmlns:a16="http://schemas.microsoft.com/office/drawing/2014/main" id="{93636BD9-9CFD-4FBE-1094-7A61AF7DCDE8}"/>
+              </a:ext>
+            </a:extLst>
+          </p:cNvPr>
+          <p:cNvGrpSpPr/>
+          <p:nvPr/>
+        </p:nvGrpSpPr>
+        <p:grpSpPr>
           <a:xfrm>
             <a:off x="612000" y="3888000"/>
-            <a:ext cx="612000" cy="612000"/>
-          </a:xfrm>
-          <a:prstGeom prst="ellipse">
-            <a:avLst/>
-          </a:prstGeom>
-          <a:solidFill>
-            <a:srgbClr val="DB0829"/>
-          </a:solidFill>
-          <a:ln>
-            <a:noFill/>
-          </a:ln>
-        </p:spPr>
-        <p:txBody>
-          <a:bodyPr anchor="ctr"/>
-          <a:lstStyle/>
-          <a:p>
-            <a:pPr algn="ctr"/>
-            <a:r>
-              <a:rPr lang="en-US" sz="2200" b="1">
-                <a:solidFill>
-                  <a:srgbClr val="FFFFFF"/>
-                </a:solidFill>
-                <a:latin typeface="Trebuchet MS"/>
-                <a:ea typeface="Trebuchet MS"/>
-              </a:rPr>
-              <a:t>3</a:t>
-            </a:r>
-          </a:p>
-        </p:txBody>
-      </p:sp>
-      <p:sp>
-        <p:nvSpPr>
-          <p:cNvPr id="100049" name="TextBox 10"/>
-          <p:cNvSpPr txBox="1"/>
-          <p:nvPr/>
-        </p:nvSpPr>
-        <p:spPr>
-          <a:xfrm>
-            <a:off x="1476000" y="3942000"/>
-            <a:ext cx="10044000" cy="414000"/>
-          </a:xfrm>
-          <a:prstGeom prst="rect">
-            <a:avLst/>
-          </a:prstGeom>
-        </p:spPr>
-        <p:txBody>
-          <a:bodyPr/>
-          <a:lstStyle/>
-          <a:p>
-            <a:r>
-              <a:rPr lang="en-US" sz="2000" b="1">
-                <a:solidFill>
-                  <a:srgbClr val="1B2430"/>
-                </a:solidFill>
-                <a:latin typeface="Trebuchet MS"/>
-                <a:ea typeface="Trebuchet MS"/>
-              </a:rPr>
-              <a:t>Tạo quy trình can thiệp có dấu vết</a:t>
-            </a:r>
-          </a:p>
-        </p:txBody>
-      </p:sp>
-      <p:sp>
-        <p:nvSpPr>
-          <p:cNvPr id="100050" name="TextBox 11"/>
-          <p:cNvSpPr txBox="1"/>
-          <p:nvPr/>
-        </p:nvSpPr>
-        <p:spPr>
-          <a:xfrm>
-            <a:off x="1476000" y="4302000"/>
-            <a:ext cx="10044000" cy="648000"/>
-          </a:xfrm>
-          <a:prstGeom prst="rect">
-            <a:avLst/>
-          </a:prstGeom>
-        </p:spPr>
-        <p:txBody>
-          <a:bodyPr/>
-          <a:lstStyle/>
-          <a:p>
-            <a:r>
-              <a:rPr lang="en-US" sz="1800">
-                <a:solidFill>
-                  <a:srgbClr val="7A8794"/>
-                </a:solidFill>
-                <a:latin typeface="Calibri"/>
-                <a:ea typeface="Calibri"/>
-              </a:rPr>
-              <a:t>Nhắc nhở qua Zalo, ghi nhật ký liên hệ — để Lead Khối theo dõi được giáo viên đã can thiệp với học viên nào, khi nào.</a:t>
-            </a:r>
-          </a:p>
-        </p:txBody>
-      </p:sp>
-      <p:sp>
-        <p:nvSpPr>
-          <p:cNvPr id="100051" name="TextBox 12"/>
-          <p:cNvSpPr/>
-          <p:nvPr/>
-        </p:nvSpPr>
-        <p:spPr>
+            <a:ext cx="10908000" cy="1062000"/>
+            <a:chOff x="612000" y="3888000"/>
+            <a:chExt cx="10908000" cy="1062000"/>
+          </a:xfrm>
+        </p:grpSpPr>
+        <p:sp>
+          <p:nvSpPr>
+            <p:cNvPr id="100048" name="TextBox 9"/>
+            <p:cNvSpPr/>
+            <p:nvPr/>
+          </p:nvSpPr>
+          <p:spPr>
+            <a:xfrm>
+              <a:off x="612000" y="3888000"/>
+              <a:ext cx="612000" cy="612000"/>
+            </a:xfrm>
+            <a:prstGeom prst="ellipse">
+              <a:avLst/>
+            </a:prstGeom>
+            <a:solidFill>
+              <a:srgbClr val="DB0829"/>
+            </a:solidFill>
+            <a:ln>
+              <a:noFill/>
+            </a:ln>
+          </p:spPr>
+          <p:txBody>
+            <a:bodyPr anchor="ctr"/>
+            <a:lstStyle/>
+            <a:p>
+              <a:pPr algn="ctr"/>
+              <a:r>
+                <a:rPr lang="en-US" sz="2200" b="1">
+                  <a:solidFill>
+                    <a:srgbClr val="FFFFFF"/>
+                  </a:solidFill>
+                  <a:latin typeface="Trebuchet MS"/>
+                  <a:ea typeface="Trebuchet MS"/>
+                </a:rPr>
+                <a:t>3</a:t>
+              </a:r>
+            </a:p>
+          </p:txBody>
+        </p:sp>
+        <p:sp>
+          <p:nvSpPr>
+            <p:cNvPr id="100049" name="TextBox 10"/>
+            <p:cNvSpPr txBox="1"/>
+            <p:nvPr/>
+          </p:nvSpPr>
+          <p:spPr>
+            <a:xfrm>
+              <a:off x="1476000" y="3942000"/>
+              <a:ext cx="10044000" cy="414000"/>
+            </a:xfrm>
+            <a:prstGeom prst="rect">
+              <a:avLst/>
+            </a:prstGeom>
+          </p:spPr>
+          <p:txBody>
+            <a:bodyPr/>
+            <a:lstStyle/>
+            <a:p>
+              <a:r>
+                <a:rPr lang="en-US" sz="2000" b="1">
+                  <a:solidFill>
+                    <a:srgbClr val="1B2430"/>
+                  </a:solidFill>
+                  <a:latin typeface="Trebuchet MS"/>
+                  <a:ea typeface="Trebuchet MS"/>
+                </a:rPr>
+                <a:t>Tạo quy trình can thiệp có dấu vết</a:t>
+              </a:r>
+            </a:p>
+          </p:txBody>
+        </p:sp>
+        <p:sp>
+          <p:nvSpPr>
+            <p:cNvPr id="100050" name="TextBox 11"/>
+            <p:cNvSpPr txBox="1"/>
+            <p:nvPr/>
+          </p:nvSpPr>
+          <p:spPr>
+            <a:xfrm>
+              <a:off x="1476000" y="4302000"/>
+              <a:ext cx="10044000" cy="648000"/>
+            </a:xfrm>
+            <a:prstGeom prst="rect">
+              <a:avLst/>
+            </a:prstGeom>
+          </p:spPr>
+          <p:txBody>
+            <a:bodyPr/>
+            <a:lstStyle/>
+            <a:p>
+              <a:r>
+                <a:rPr lang="en-US" sz="1800">
+                  <a:solidFill>
+                    <a:srgbClr val="7A8794"/>
+                  </a:solidFill>
+                  <a:latin typeface="Calibri"/>
+                  <a:ea typeface="Calibri"/>
+                </a:rPr>
+                <a:t>Nhắc nhở qua Zalo, ghi nhật ký liên hệ — để Lead Khối theo dõi được giáo viên đã can thiệp với học viên nào, khi nào.</a:t>
+              </a:r>
+            </a:p>
+          </p:txBody>
+        </p:sp>
+      </p:grpSp>
+      <p:grpSp>
+        <p:nvGrpSpPr>
+          <p:cNvPr id="5" name="Group 4">
+            <a:extLst>
+              <a:ext uri="{FF2B5EF4-FFF2-40B4-BE49-F238E27FC236}">
+                <a16:creationId xmlns:a16="http://schemas.microsoft.com/office/drawing/2014/main" id="{0E2219BD-341A-D636-F1E9-4BC09EC7E858}"/>
+              </a:ext>
+            </a:extLst>
+          </p:cNvPr>
+          <p:cNvGrpSpPr/>
+          <p:nvPr/>
+        </p:nvGrpSpPr>
+        <p:grpSpPr>
           <a:xfrm>
             <a:off x="612000" y="5148000"/>
-            <a:ext cx="612000" cy="612000"/>
-          </a:xfrm>
-          <a:prstGeom prst="ellipse">
-            <a:avLst/>
-          </a:prstGeom>
-          <a:solidFill>
-            <a:srgbClr val="DB0829"/>
-          </a:solidFill>
-          <a:ln>
-            <a:noFill/>
-          </a:ln>
-        </p:spPr>
-        <p:txBody>
-          <a:bodyPr anchor="ctr"/>
-          <a:lstStyle/>
-          <a:p>
-            <a:pPr algn="ctr"/>
-            <a:r>
-              <a:rPr lang="en-US" sz="2200" b="1">
-                <a:solidFill>
-                  <a:srgbClr val="FFFFFF"/>
-                </a:solidFill>
-                <a:latin typeface="Trebuchet MS"/>
-                <a:ea typeface="Trebuchet MS"/>
-              </a:rPr>
-              <a:t>4</a:t>
-            </a:r>
-          </a:p>
-        </p:txBody>
-      </p:sp>
-      <p:sp>
-        <p:nvSpPr>
-          <p:cNvPr id="100052" name="TextBox 13"/>
-          <p:cNvSpPr txBox="1"/>
-          <p:nvPr/>
-        </p:nvSpPr>
-        <p:spPr>
-          <a:xfrm>
-            <a:off x="1476000" y="5202000"/>
-            <a:ext cx="10044000" cy="414000"/>
-          </a:xfrm>
-          <a:prstGeom prst="rect">
-            <a:avLst/>
-          </a:prstGeom>
-        </p:spPr>
-        <p:txBody>
-          <a:bodyPr/>
-          <a:lstStyle/>
-          <a:p>
-            <a:r>
-              <a:rPr lang="en-US" sz="2000" b="1">
-                <a:solidFill>
-                  <a:srgbClr val="1B2430"/>
-                </a:solidFill>
-                <a:latin typeface="Trebuchet MS"/>
-                <a:ea typeface="Trebuchet MS"/>
-              </a:rPr>
-              <a:t>Đặt nền móng dữ liệu Postgres + API</a:t>
-            </a:r>
-          </a:p>
-        </p:txBody>
-      </p:sp>
-      <p:sp>
-        <p:nvSpPr>
-          <p:cNvPr id="100053" name="TextBox 14"/>
-          <p:cNvSpPr txBox="1"/>
-          <p:nvPr/>
-        </p:nvSpPr>
-        <p:spPr>
-          <a:xfrm>
-            <a:off x="1476000" y="5562000"/>
-            <a:ext cx="10044000" cy="648000"/>
-          </a:xfrm>
-          <a:prstGeom prst="rect">
-            <a:avLst/>
-          </a:prstGeom>
-        </p:spPr>
-        <p:txBody>
-          <a:bodyPr/>
-          <a:lstStyle/>
-          <a:p>
-            <a:r>
-              <a:rPr lang="en-US" sz="1800">
-                <a:solidFill>
-                  <a:srgbClr val="7A8794"/>
-                </a:solidFill>
-                <a:latin typeface="Calibri"/>
-                <a:ea typeface="Calibri"/>
-              </a:rPr>
-              <a:t>Để về sau tự động hoá hoàn toàn việc nạp dữ liệu từ hệ thống portal, thay vì thao tác thủ công trên Google Sheets.</a:t>
-            </a:r>
-          </a:p>
-        </p:txBody>
-      </p:sp>
+            <a:ext cx="10908000" cy="1062000"/>
+            <a:chOff x="612000" y="5148000"/>
+            <a:chExt cx="10908000" cy="1062000"/>
+          </a:xfrm>
+        </p:grpSpPr>
+        <p:sp>
+          <p:nvSpPr>
+            <p:cNvPr id="100051" name="TextBox 12"/>
+            <p:cNvSpPr/>
+            <p:nvPr/>
+          </p:nvSpPr>
+          <p:spPr>
+            <a:xfrm>
+              <a:off x="612000" y="5148000"/>
+              <a:ext cx="612000" cy="612000"/>
+            </a:xfrm>
+            <a:prstGeom prst="ellipse">
+              <a:avLst/>
+            </a:prstGeom>
+            <a:solidFill>
+              <a:srgbClr val="DB0829"/>
+            </a:solidFill>
+            <a:ln>
+              <a:noFill/>
+            </a:ln>
+          </p:spPr>
+          <p:txBody>
+            <a:bodyPr anchor="ctr"/>
+            <a:lstStyle/>
+            <a:p>
+              <a:pPr algn="ctr"/>
+              <a:r>
+                <a:rPr lang="en-US" sz="2200" b="1">
+                  <a:solidFill>
+                    <a:srgbClr val="FFFFFF"/>
+                  </a:solidFill>
+                  <a:latin typeface="Trebuchet MS"/>
+                  <a:ea typeface="Trebuchet MS"/>
+                </a:rPr>
+                <a:t>4</a:t>
+              </a:r>
+            </a:p>
+          </p:txBody>
+        </p:sp>
+        <p:sp>
+          <p:nvSpPr>
+            <p:cNvPr id="100052" name="TextBox 13"/>
+            <p:cNvSpPr txBox="1"/>
+            <p:nvPr/>
+          </p:nvSpPr>
+          <p:spPr>
+            <a:xfrm>
+              <a:off x="1476000" y="5202000"/>
+              <a:ext cx="10044000" cy="414000"/>
+            </a:xfrm>
+            <a:prstGeom prst="rect">
+              <a:avLst/>
+            </a:prstGeom>
+          </p:spPr>
+          <p:txBody>
+            <a:bodyPr/>
+            <a:lstStyle/>
+            <a:p>
+              <a:r>
+                <a:rPr lang="en-US" sz="2000" b="1">
+                  <a:solidFill>
+                    <a:srgbClr val="1B2430"/>
+                  </a:solidFill>
+                  <a:latin typeface="Trebuchet MS"/>
+                  <a:ea typeface="Trebuchet MS"/>
+                </a:rPr>
+                <a:t>Đặt nền móng dữ liệu Postgres + API</a:t>
+              </a:r>
+            </a:p>
+          </p:txBody>
+        </p:sp>
+        <p:sp>
+          <p:nvSpPr>
+            <p:cNvPr id="100053" name="TextBox 14"/>
+            <p:cNvSpPr txBox="1"/>
+            <p:nvPr/>
+          </p:nvSpPr>
+          <p:spPr>
+            <a:xfrm>
+              <a:off x="1476000" y="5562000"/>
+              <a:ext cx="10044000" cy="648000"/>
+            </a:xfrm>
+            <a:prstGeom prst="rect">
+              <a:avLst/>
+            </a:prstGeom>
+          </p:spPr>
+          <p:txBody>
+            <a:bodyPr/>
+            <a:lstStyle/>
+            <a:p>
+              <a:r>
+                <a:rPr lang="en-US" sz="1800">
+                  <a:solidFill>
+                    <a:srgbClr val="7A8794"/>
+                  </a:solidFill>
+                  <a:latin typeface="Calibri"/>
+                  <a:ea typeface="Calibri"/>
+                </a:rPr>
+                <a:t>Để về sau tự động hoá hoàn toàn việc nạp dữ liệu từ hệ thống portal, thay vì thao tác thủ công trên Google Sheets.</a:t>
+              </a:r>
+            </a:p>
+          </p:txBody>
+        </p:sp>
+      </p:grpSp>
     </p:spTree>
   </p:cSld>
   <p:clrMapOvr>
@@ -7331,6 +7194,216 @@
   <p:transition>
     <p:fade/>
   </p:transition>
+  <p:timing>
+    <p:tnLst>
+      <p:par>
+        <p:cTn id="1" dur="indefinite" restart="never" nodeType="tmRoot">
+          <p:childTnLst>
+            <p:seq concurrent="1" nextAc="seek">
+              <p:cTn id="2" dur="indefinite" nodeType="mainSeq">
+                <p:childTnLst>
+                  <p:par>
+                    <p:cTn id="3" fill="hold">
+                      <p:stCondLst>
+                        <p:cond delay="indefinite"/>
+                      </p:stCondLst>
+                      <p:childTnLst>
+                        <p:par>
+                          <p:cTn id="4" fill="hold">
+                            <p:stCondLst>
+                              <p:cond delay="0"/>
+                            </p:stCondLst>
+                            <p:childTnLst>
+                              <p:par>
+                                <p:cTn id="5" presetID="1" presetClass="entr" presetSubtype="0" fill="hold" nodeType="clickEffect">
+                                  <p:stCondLst>
+                                    <p:cond delay="0"/>
+                                  </p:stCondLst>
+                                  <p:childTnLst>
+                                    <p:set>
+                                      <p:cBhvr>
+                                        <p:cTn id="6" dur="1" fill="hold">
+                                          <p:stCondLst>
+                                            <p:cond delay="0"/>
+                                          </p:stCondLst>
+                                        </p:cTn>
+                                        <p:tgtEl>
+                                          <p:spTgt spid="2"/>
+                                        </p:tgtEl>
+                                        <p:attrNameLst>
+                                          <p:attrName>style.visibility</p:attrName>
+                                        </p:attrNameLst>
+                                      </p:cBhvr>
+                                      <p:to>
+                                        <p:strVal val="visible"/>
+                                      </p:to>
+                                    </p:set>
+                                  </p:childTnLst>
+                                </p:cTn>
+                              </p:par>
+                            </p:childTnLst>
+                          </p:cTn>
+                        </p:par>
+                      </p:childTnLst>
+                    </p:cTn>
+                  </p:par>
+                  <p:par>
+                    <p:cTn id="7" fill="hold">
+                      <p:stCondLst>
+                        <p:cond delay="indefinite"/>
+                      </p:stCondLst>
+                      <p:childTnLst>
+                        <p:par>
+                          <p:cTn id="8" fill="hold">
+                            <p:stCondLst>
+                              <p:cond delay="0"/>
+                            </p:stCondLst>
+                            <p:childTnLst>
+                              <p:par>
+                                <p:cTn id="9" presetID="1" presetClass="entr" presetSubtype="0" fill="hold" nodeType="clickEffect">
+                                  <p:stCondLst>
+                                    <p:cond delay="0"/>
+                                  </p:stCondLst>
+                                  <p:childTnLst>
+                                    <p:set>
+                                      <p:cBhvr>
+                                        <p:cTn id="10" dur="1" fill="hold">
+                                          <p:stCondLst>
+                                            <p:cond delay="0"/>
+                                          </p:stCondLst>
+                                        </p:cTn>
+                                        <p:tgtEl>
+                                          <p:spTgt spid="3"/>
+                                        </p:tgtEl>
+                                        <p:attrNameLst>
+                                          <p:attrName>style.visibility</p:attrName>
+                                        </p:attrNameLst>
+                                      </p:cBhvr>
+                                      <p:to>
+                                        <p:strVal val="visible"/>
+                                      </p:to>
+                                    </p:set>
+                                  </p:childTnLst>
+                                </p:cTn>
+                              </p:par>
+                            </p:childTnLst>
+                          </p:cTn>
+                        </p:par>
+                      </p:childTnLst>
+                    </p:cTn>
+                  </p:par>
+                  <p:par>
+                    <p:cTn id="11" fill="hold">
+                      <p:stCondLst>
+                        <p:cond delay="indefinite"/>
+                      </p:stCondLst>
+                      <p:childTnLst>
+                        <p:par>
+                          <p:cTn id="12" fill="hold">
+                            <p:stCondLst>
+                              <p:cond delay="0"/>
+                            </p:stCondLst>
+                            <p:childTnLst>
+                              <p:par>
+                                <p:cTn id="13" presetID="1" presetClass="entr" presetSubtype="0" fill="hold" nodeType="clickEffect">
+                                  <p:stCondLst>
+                                    <p:cond delay="0"/>
+                                  </p:stCondLst>
+                                  <p:childTnLst>
+                                    <p:set>
+                                      <p:cBhvr>
+                                        <p:cTn id="14" dur="1" fill="hold">
+                                          <p:stCondLst>
+                                            <p:cond delay="0"/>
+                                          </p:stCondLst>
+                                        </p:cTn>
+                                        <p:tgtEl>
+                                          <p:spTgt spid="4"/>
+                                        </p:tgtEl>
+                                        <p:attrNameLst>
+                                          <p:attrName>style.visibility</p:attrName>
+                                        </p:attrNameLst>
+                                      </p:cBhvr>
+                                      <p:to>
+                                        <p:strVal val="visible"/>
+                                      </p:to>
+                                    </p:set>
+                                  </p:childTnLst>
+                                </p:cTn>
+                              </p:par>
+                            </p:childTnLst>
+                          </p:cTn>
+                        </p:par>
+                      </p:childTnLst>
+                    </p:cTn>
+                  </p:par>
+                  <p:par>
+                    <p:cTn id="15" fill="hold">
+                      <p:stCondLst>
+                        <p:cond delay="indefinite"/>
+                      </p:stCondLst>
+                      <p:childTnLst>
+                        <p:par>
+                          <p:cTn id="16" fill="hold">
+                            <p:stCondLst>
+                              <p:cond delay="0"/>
+                            </p:stCondLst>
+                            <p:childTnLst>
+                              <p:par>
+                                <p:cTn id="17" presetID="1" presetClass="entr" presetSubtype="0" fill="hold" nodeType="clickEffect">
+                                  <p:stCondLst>
+                                    <p:cond delay="0"/>
+                                  </p:stCondLst>
+                                  <p:childTnLst>
+                                    <p:set>
+                                      <p:cBhvr>
+                                        <p:cTn id="18" dur="1" fill="hold">
+                                          <p:stCondLst>
+                                            <p:cond delay="0"/>
+                                          </p:stCondLst>
+                                        </p:cTn>
+                                        <p:tgtEl>
+                                          <p:spTgt spid="5"/>
+                                        </p:tgtEl>
+                                        <p:attrNameLst>
+                                          <p:attrName>style.visibility</p:attrName>
+                                        </p:attrNameLst>
+                                      </p:cBhvr>
+                                      <p:to>
+                                        <p:strVal val="visible"/>
+                                      </p:to>
+                                    </p:set>
+                                  </p:childTnLst>
+                                </p:cTn>
+                              </p:par>
+                            </p:childTnLst>
+                          </p:cTn>
+                        </p:par>
+                      </p:childTnLst>
+                    </p:cTn>
+                  </p:par>
+                </p:childTnLst>
+              </p:cTn>
+              <p:prevCondLst>
+                <p:cond evt="onPrev" delay="0">
+                  <p:tgtEl>
+                    <p:sldTgt/>
+                  </p:tgtEl>
+                </p:cond>
+              </p:prevCondLst>
+              <p:nextCondLst>
+                <p:cond evt="onNext" delay="0">
+                  <p:tgtEl>
+                    <p:sldTgt/>
+                  </p:tgtEl>
+                </p:cond>
+              </p:nextCondLst>
+            </p:seq>
+          </p:childTnLst>
+        </p:cTn>
+      </p:par>
+    </p:tnLst>
+  </p:timing>
 </p:sld>
 </file>
 
@@ -8301,7 +8374,7 @@
                 <a:latin typeface="Trebuchet MS"/>
                 <a:ea typeface="Trebuchet MS"/>
               </a:rPr>
-              <a:t>Ngưỡng cấu hình tập trung</a:t>
+              <a:t>Cấu hình tập trung</a:t>
             </a:r>
           </a:p>
         </p:txBody>
@@ -8315,7 +8388,7 @@
         <p:spPr>
           <a:xfrm>
             <a:off x="6721200" y="3456000"/>
-            <a:ext cx="4392000" cy="1746000"/>
+            <a:ext cx="4392000" cy="1344600"/>
           </a:xfrm>
           <a:prstGeom prst="rect">
             <a:avLst/>
@@ -8333,7 +8406,7 @@
                 <a:latin typeface="Calibri"/>
                 <a:ea typeface="Calibri"/>
               </a:rPr>
-              <a:t>Nhãn, pass chuẩn, pass mềm, cảnh báo lớp — tất cả cấu hình tại một nơi, giúp Lead/Ban Giám Hiệu điều chỉnh chính sách mà không cần đổi quy trình thủ công ở từng lớp.</a:t>
+              <a:t>Nhãn, pass chuẩn, pass mềm, cảnh báo lớp — tất cả cấu hình tại một nơi, giúp Lead điều chỉnh chính sách mà không cần đổi quy trình thủ công ở từng lớp.</a:t>
             </a:r>
           </a:p>
         </p:txBody>

</xml_diff>